<commit_message>
fix: follow PPTX presentation order and relationships
</commit_message>
<xml_diff>
--- a/benchmarks/extraction/fixtures/repeated-media.pptx
+++ b/benchmarks/extraction/fixtures/repeated-media.pptx
@@ -1,3 +1,58 @@
+
+<file path=ppt/presentation.xml><?xml version="1.0" encoding="utf-8"?>
+<p:presentation xmlns:p="http://schemas.openxmlformats.org/presentationml/2006/main" xmlns:r="http://schemas.openxmlformats.org/officeDocument/2006/relationships">
+  <p:sldIdLst>
+    <p:sldId id="256" r:id="s1"/>
+    <p:sldId id="257" r:id="s2"/>
+    <p:sldId id="258" r:id="s3"/>
+    <p:sldId id="259" r:id="s4"/>
+    <p:sldId id="260" r:id="s5"/>
+    <p:sldId id="261" r:id="s6"/>
+    <p:sldId id="262" r:id="s7"/>
+    <p:sldId id="263" r:id="s8"/>
+    <p:sldId id="264" r:id="s9"/>
+    <p:sldId id="265" r:id="s10"/>
+    <p:sldId id="266" r:id="s11"/>
+    <p:sldId id="267" r:id="s12"/>
+    <p:sldId id="268" r:id="s13"/>
+    <p:sldId id="269" r:id="s14"/>
+    <p:sldId id="270" r:id="s15"/>
+    <p:sldId id="271" r:id="s16"/>
+    <p:sldId id="272" r:id="s17"/>
+    <p:sldId id="273" r:id="s18"/>
+    <p:sldId id="274" r:id="s19"/>
+    <p:sldId id="275" r:id="s20"/>
+    <p:sldId id="276" r:id="s21"/>
+    <p:sldId id="277" r:id="s22"/>
+    <p:sldId id="278" r:id="s23"/>
+    <p:sldId id="279" r:id="s24"/>
+    <p:sldId id="280" r:id="s25"/>
+    <p:sldId id="281" r:id="s26"/>
+    <p:sldId id="282" r:id="s27"/>
+    <p:sldId id="283" r:id="s28"/>
+    <p:sldId id="284" r:id="s29"/>
+    <p:sldId id="285" r:id="s30"/>
+    <p:sldId id="286" r:id="s31"/>
+    <p:sldId id="287" r:id="s32"/>
+    <p:sldId id="288" r:id="s33"/>
+    <p:sldId id="289" r:id="s34"/>
+    <p:sldId id="290" r:id="s35"/>
+    <p:sldId id="291" r:id="s36"/>
+    <p:sldId id="292" r:id="s37"/>
+    <p:sldId id="293" r:id="s38"/>
+    <p:sldId id="294" r:id="s39"/>
+    <p:sldId id="295" r:id="s40"/>
+    <p:sldId id="296" r:id="s41"/>
+    <p:sldId id="297" r:id="s42"/>
+    <p:sldId id="298" r:id="s43"/>
+    <p:sldId id="299" r:id="s44"/>
+    <p:sldId id="300" r:id="s45"/>
+    <p:sldId id="301" r:id="s46"/>
+    <p:sldId id="302" r:id="s47"/>
+    <p:sldId id="303" r:id="s48"/>
+  </p:sldIdLst>
+</p:presentation>
+</file>
 
 <file path=ppt/slides/slide1.xml><?xml version="1.0" encoding="utf-8"?>
 <sld>

</xml_diff>